<commit_message>
updated requirement and frontend html code
</commit_message>
<xml_diff>
--- a/wireframe/wireframe.pptx
+++ b/wireframe/wireframe.pptx
@@ -3396,8 +3396,8 @@
         </p:nvSpPr>
         <p:spPr>
           <a:xfrm>
-            <a:off x="3047215" y="2138695"/>
-            <a:ext cx="6094428" cy="2585323"/>
+            <a:off x="1677971" y="1074657"/>
+            <a:ext cx="7463672" cy="2031325"/>
           </a:xfrm>
           <a:prstGeom prst="rect">
             <a:avLst/>
@@ -3411,7 +3411,7 @@
           <a:lstStyle/>
           <a:p>
             <a:r>
-              <a:rPr lang="en-US"/>
+              <a:rPr lang="en-US" dirty="0"/>
               <a:t>Step 1 (Done ✅) → Visual Wireframe + Architecture Plan</a:t>
             </a:r>
           </a:p>

</xml_diff>